<commit_message>
Put real product screenshots in the pitch deck
Slide 5 showed a hand-drawn approximation of the dashboard and slide 8
asserted that the app will tell you not to buy. Both are now the actual
screens, captured from a production build.

The screenshots argue better than the slides did. The dashboard capture
carries the stress-test warning — "a date isn't an approval, at $92,000
you likely wouldn't qualify" — so the honesty claim is demonstrated rather
than stated. The rent-vs-buy capture shows the verdict "Renting +
investing wins", which is the whole ethics argument in one image: a
company paid by referral fees could not ship that screen.

capture-ui.mjs is committed so the images can be regenerated when the UI
moves, and it asserts the "renting wins" verdict is actually on screen
before saving rather than trusting the inputs to produce it.

Co-Authored-By: Claude Opus 5 <noreply@anthropic.com>
Claude-Session: https://claude.ai/code/session_019WKzGoyENXa8KtvmiHdCC2
</commit_message>
<xml_diff>
--- a/apps/keydate/pitch/KeyDate-JCI-Edmonton-Montserrat.pptx
+++ b/apps/keydate/pitch/KeyDate-JCI-Edmonton-Montserrat.pptx
@@ -3797,201 +3797,73 @@
           </a:p>
         </p:txBody>
       </p:sp>
-      <p:sp>
-        <p:nvSpPr>
-          <p:cNvPr id="13" name="Shape 11"/>
-          <p:cNvSpPr/>
-          <p:nvPr/>
-        </p:nvSpPr>
-        <p:spPr>
-          <a:xfrm>
-            <a:off x="8138160" y="2148840"/>
-            <a:ext cx="3364992" cy="3246120"/>
-          </a:xfrm>
-          <a:prstGeom prst="roundRect">
-            <a:avLst>
-              <a:gd name="adj" fmla="val 5070"/>
-            </a:avLst>
-          </a:prstGeom>
-          <a:solidFill>
-            <a:srgbClr val="1E4D3B"/>
-          </a:solidFill>
-          <a:ln w="12700">
-            <a:solidFill>
-              <a:srgbClr val="1E4D3B"/>
-            </a:solidFill>
-            <a:prstDash val="solid"/>
-          </a:ln>
-        </p:spPr>
-      </p:sp>
-      <p:sp>
-        <p:nvSpPr>
-          <p:cNvPr id="14" name="Text 12"/>
-          <p:cNvSpPr/>
-          <p:nvPr/>
-        </p:nvSpPr>
-        <p:spPr>
-          <a:xfrm>
-            <a:off x="8458200" y="2560320"/>
-            <a:ext cx="2743200" cy="274320"/>
-          </a:xfrm>
-          <a:prstGeom prst="rect">
-            <a:avLst/>
-          </a:prstGeom>
-          <a:noFill/>
-          <a:ln/>
-        </p:spPr>
-        <p:txBody>
-          <a:bodyPr wrap="square" lIns="0" tIns="0" rIns="0" bIns="0" rtlCol="0" anchor="ctr"/>
-          <a:lstStyle/>
-          <a:p>
-            <a:pPr indent="0" marL="0">
-              <a:buNone/>
-            </a:pPr>
-            <a:r>
-              <a:rPr lang="en-US" sz="1100" b="1" spc="200" kern="0" dirty="0">
-                <a:solidFill>
-                  <a:srgbClr val="E8B84B"/>
-                </a:solidFill>
-                <a:latin typeface="Montserrat" pitchFamily="34" charset="0"/>
-                <a:ea typeface="Montserrat" pitchFamily="34" charset="-122"/>
-                <a:cs typeface="Montserrat" pitchFamily="34" charset="-120"/>
-              </a:rPr>
-              <a:t>KEYS IN HAND</a:t>
-            </a:r>
-            <a:endParaRPr lang="en-US" sz="1100" dirty="0"/>
-          </a:p>
-        </p:txBody>
-      </p:sp>
-      <p:sp>
-        <p:nvSpPr>
-          <p:cNvPr id="15" name="Text 13"/>
-          <p:cNvSpPr/>
-          <p:nvPr/>
-        </p:nvSpPr>
-        <p:spPr>
-          <a:xfrm>
-            <a:off x="8458200" y="2926080"/>
-            <a:ext cx="2834640" cy="822960"/>
-          </a:xfrm>
-          <a:prstGeom prst="rect">
-            <a:avLst/>
-          </a:prstGeom>
-          <a:noFill/>
-          <a:ln/>
-        </p:spPr>
-        <p:txBody>
-          <a:bodyPr wrap="square" lIns="0" tIns="0" rIns="0" bIns="0" rtlCol="0" anchor="ctr"/>
-          <a:lstStyle/>
-          <a:p>
-            <a:pPr indent="0" marL="0">
-              <a:buNone/>
-            </a:pPr>
-            <a:r>
-              <a:rPr lang="en-US" sz="3300" b="1" dirty="0">
-                <a:solidFill>
-                  <a:srgbClr val="FFFFFF"/>
-                </a:solidFill>
-                <a:latin typeface="Montserrat" pitchFamily="34" charset="0"/>
-                <a:ea typeface="Montserrat" pitchFamily="34" charset="-122"/>
-                <a:cs typeface="Montserrat" pitchFamily="34" charset="-120"/>
-              </a:rPr>
-              <a:t>June 2029</a:t>
-            </a:r>
-            <a:endParaRPr lang="en-US" sz="3300" dirty="0"/>
-          </a:p>
-        </p:txBody>
-      </p:sp>
-      <p:sp>
-        <p:nvSpPr>
-          <p:cNvPr id="16" name="Shape 14"/>
-          <p:cNvSpPr/>
-          <p:nvPr/>
-        </p:nvSpPr>
-        <p:spPr>
-          <a:xfrm>
-            <a:off x="8458200" y="3977640"/>
-            <a:ext cx="2743200" cy="256032"/>
-          </a:xfrm>
-          <a:prstGeom prst="roundRect">
-            <a:avLst>
-              <a:gd name="adj" fmla="val 50000"/>
-            </a:avLst>
-          </a:prstGeom>
-          <a:solidFill>
-            <a:srgbClr val="2C6349"/>
-          </a:solidFill>
-          <a:ln w="12700">
-            <a:solidFill>
-              <a:srgbClr val="2C6349"/>
-            </a:solidFill>
-            <a:prstDash val="solid"/>
-          </a:ln>
-        </p:spPr>
-      </p:sp>
-      <p:sp>
-        <p:nvSpPr>
-          <p:cNvPr id="17" name="Shape 15"/>
-          <p:cNvSpPr/>
-          <p:nvPr/>
-        </p:nvSpPr>
-        <p:spPr>
-          <a:xfrm>
-            <a:off x="8458200" y="3977640"/>
-            <a:ext cx="1591056" cy="256032"/>
-          </a:xfrm>
-          <a:prstGeom prst="roundRect">
-            <a:avLst>
-              <a:gd name="adj" fmla="val 50000"/>
-            </a:avLst>
-          </a:prstGeom>
-          <a:solidFill>
-            <a:srgbClr val="3FA672"/>
-          </a:solidFill>
-          <a:ln w="12700">
-            <a:solidFill>
-              <a:srgbClr val="3FA672"/>
-            </a:solidFill>
-            <a:prstDash val="solid"/>
-          </a:ln>
-        </p:spPr>
-      </p:sp>
-      <p:sp>
-        <p:nvSpPr>
-          <p:cNvPr id="18" name="Text 16"/>
-          <p:cNvSpPr/>
-          <p:nvPr/>
-        </p:nvSpPr>
-        <p:spPr>
-          <a:xfrm>
-            <a:off x="8458200" y="4370832"/>
-            <a:ext cx="2834640" cy="320040"/>
-          </a:xfrm>
-          <a:prstGeom prst="rect">
-            <a:avLst/>
-          </a:prstGeom>
-          <a:noFill/>
-          <a:ln/>
-        </p:spPr>
-        <p:txBody>
-          <a:bodyPr wrap="square" lIns="0" tIns="0" rIns="0" bIns="0" rtlCol="0" anchor="ctr"/>
-          <a:lstStyle/>
-          <a:p>
-            <a:pPr indent="0" marL="0">
-              <a:buNone/>
-            </a:pPr>
-            <a:r>
-              <a:rPr lang="en-US" sz="1300" dirty="0">
-                <a:solidFill>
-                  <a:srgbClr val="E3F2E9"/>
-                </a:solidFill>
-                <a:latin typeface="Montserrat" pitchFamily="34" charset="0"/>
-                <a:ea typeface="Montserrat" pitchFamily="34" charset="-122"/>
-                <a:cs typeface="Montserrat" pitchFamily="34" charset="-120"/>
-              </a:rPr>
-              <a:t>58% of the way there</a:t>
-            </a:r>
-            <a:endParaRPr lang="en-US" sz="1300" dirty="0"/>
+      <p:pic>
+        <p:nvPicPr>
+          <p:cNvPr id="13" name="Image 0" descr="preencoded.png">    </p:cNvPr>
+          <p:cNvPicPr>
+            <a:picLocks noChangeAspect="1"/>
+          </p:cNvPicPr>
+          <p:nvPr/>
+        </p:nvPicPr>
+        <p:blipFill>
+          <a:blip r:embed="rId1"/>
+          <a:stretch>
+            <a:fillRect/>
+          </a:stretch>
+        </p:blipFill>
+        <p:spPr>
+          <a:xfrm>
+            <a:off x="8028432" y="1783080"/>
+            <a:ext cx="3291840" cy="3657600"/>
+          </a:xfrm>
+          <a:prstGeom prst="rect">
+            <a:avLst/>
+          </a:prstGeom>
+          <a:effectLst>
+            <a:outerShdw sx="100000" sy="100000" kx="0" ky="0" algn="bl" rotWithShape="0" blurRad="177800" dist="50800" dir="5400000">
+              <a:srgbClr val="17302A">
+                <a:alpha val="28000"/>
+              </a:srgbClr>
+            </a:outerShdw>
+          </a:effectLst>
+        </p:spPr>
+      </p:pic>
+      <p:sp>
+        <p:nvSpPr>
+          <p:cNvPr id="14" name="Text 11"/>
+          <p:cNvSpPr/>
+          <p:nvPr/>
+        </p:nvSpPr>
+        <p:spPr>
+          <a:xfrm>
+            <a:off x="8028432" y="5532120"/>
+            <a:ext cx="3291840" cy="320040"/>
+          </a:xfrm>
+          <a:prstGeom prst="rect">
+            <a:avLst/>
+          </a:prstGeom>
+          <a:noFill/>
+          <a:ln/>
+        </p:spPr>
+        <p:txBody>
+          <a:bodyPr wrap="square" lIns="0" tIns="0" rIns="0" bIns="0" rtlCol="0" anchor="ctr"/>
+          <a:lstStyle/>
+          <a:p>
+            <a:pPr algn="ctr" indent="0" marL="0">
+              <a:buNone/>
+            </a:pPr>
+            <a:r>
+              <a:rPr lang="en-US" sz="1200" dirty="0">
+                <a:solidFill>
+                  <a:srgbClr val="5C6F66"/>
+                </a:solidFill>
+                <a:latin typeface="Montserrat" pitchFamily="34" charset="0"/>
+                <a:ea typeface="Montserrat" pitchFamily="34" charset="-122"/>
+                <a:cs typeface="Montserrat" pitchFamily="34" charset="-120"/>
+              </a:rPr>
+              <a:t>Real screen, real plan</a:t>
+            </a:r>
+            <a:endParaRPr lang="en-US" sz="1200" dirty="0"/>
           </a:p>
         </p:txBody>
       </p:sp>
@@ -5031,12 +4903,12 @@
         </p:nvSpPr>
         <p:spPr>
           <a:xfrm>
-            <a:off x="685800" y="2331720"/>
-            <a:ext cx="5074920" cy="2194560"/>
+            <a:off x="685800" y="2103120"/>
+            <a:ext cx="5760720" cy="1417320"/>
           </a:xfrm>
           <a:prstGeom prst="roundRect">
             <a:avLst>
-              <a:gd name="adj" fmla="val 6667"/>
+              <a:gd name="adj" fmla="val 10323"/>
             </a:avLst>
           </a:prstGeom>
           <a:solidFill>
@@ -5058,8 +4930,8 @@
         </p:nvSpPr>
         <p:spPr>
           <a:xfrm>
-            <a:off x="1143000" y="2331720"/>
-            <a:ext cx="4297680" cy="2194560"/>
+            <a:off x="1143000" y="2103120"/>
+            <a:ext cx="4937760" cy="1417320"/>
           </a:xfrm>
           <a:prstGeom prst="rect">
             <a:avLst/>
@@ -5072,9 +4944,6 @@
           <a:lstStyle/>
           <a:p>
             <a:pPr indent="0" marL="0">
-              <a:lnSpc>
-                <a:spcPts val="3400"/>
-              </a:lnSpc>
               <a:buNone/>
             </a:pPr>
             <a:r>
@@ -5086,30 +4955,10 @@
                 <a:ea typeface="Montserrat" pitchFamily="34" charset="-122"/>
                 <a:cs typeface="Montserrat" pitchFamily="34" charset="-120"/>
               </a:rPr>
-              <a:t>We never sell you</a:t>
+              <a:t>We never sell you to brokers.</a:t>
             </a:r>
             <a:endParaRPr lang="en-US" sz="2300" dirty="0"/>
           </a:p>
-          <a:p>
-            <a:pPr indent="0" marL="0">
-              <a:lnSpc>
-                <a:spcPts val="3400"/>
-              </a:lnSpc>
-              <a:buNone/>
-            </a:pPr>
-            <a:r>
-              <a:rPr lang="en-US" sz="2300" b="1" dirty="0">
-                <a:solidFill>
-                  <a:srgbClr val="FFFFFF"/>
-                </a:solidFill>
-                <a:latin typeface="Montserrat" pitchFamily="34" charset="0"/>
-                <a:ea typeface="Montserrat" pitchFamily="34" charset="-122"/>
-                <a:cs typeface="Montserrat" pitchFamily="34" charset="-120"/>
-              </a:rPr>
-              <a:t>to brokers.</a:t>
-            </a:r>
-            <a:endParaRPr lang="en-US" sz="2300" dirty="0"/>
-          </a:p>
         </p:txBody>
       </p:sp>
       <p:sp>
@@ -5120,12 +4969,12 @@
         </p:nvSpPr>
         <p:spPr>
           <a:xfrm>
-            <a:off x="6217920" y="2331720"/>
-            <a:ext cx="5074920" cy="2194560"/>
+            <a:off x="685800" y="3703320"/>
+            <a:ext cx="5760720" cy="1417320"/>
           </a:xfrm>
           <a:prstGeom prst="roundRect">
             <a:avLst>
-              <a:gd name="adj" fmla="val 6667"/>
+              <a:gd name="adj" fmla="val 10323"/>
             </a:avLst>
           </a:prstGeom>
           <a:solidFill>
@@ -5147,8 +4996,8 @@
         </p:nvSpPr>
         <p:spPr>
           <a:xfrm>
-            <a:off x="6675120" y="2331720"/>
-            <a:ext cx="4297680" cy="2194560"/>
+            <a:off x="1143000" y="3703320"/>
+            <a:ext cx="4937760" cy="1417320"/>
           </a:xfrm>
           <a:prstGeom prst="rect">
             <a:avLst/>
@@ -5161,9 +5010,6 @@
           <a:lstStyle/>
           <a:p>
             <a:pPr indent="0" marL="0">
-              <a:lnSpc>
-                <a:spcPts val="3400"/>
-              </a:lnSpc>
               <a:buNone/>
             </a:pPr>
             <a:r>
@@ -5175,58 +5021,69 @@
                 <a:ea typeface="Montserrat" pitchFamily="34" charset="-122"/>
                 <a:cs typeface="Montserrat" pitchFamily="34" charset="-120"/>
               </a:rPr>
-              <a:t>We built the tool</a:t>
+              <a:t>We built the tool that says don’t buy.</a:t>
             </a:r>
             <a:endParaRPr lang="en-US" sz="2300" dirty="0"/>
           </a:p>
+        </p:txBody>
+      </p:sp>
+      <p:pic>
+        <p:nvPicPr>
+          <p:cNvPr id="8" name="Image 0" descr="preencoded.png">    </p:cNvPr>
+          <p:cNvPicPr>
+            <a:picLocks noChangeAspect="1"/>
+          </p:cNvPicPr>
+          <p:nvPr/>
+        </p:nvPicPr>
+        <p:blipFill>
+          <a:blip r:embed="rId1"/>
+          <a:stretch>
+            <a:fillRect/>
+          </a:stretch>
+        </p:blipFill>
+        <p:spPr>
+          <a:xfrm>
+            <a:off x="6967728" y="2103120"/>
+            <a:ext cx="4535424" cy="3913632"/>
+          </a:xfrm>
+          <a:prstGeom prst="rect">
+            <a:avLst/>
+          </a:prstGeom>
+          <a:effectLst>
+            <a:outerShdw sx="100000" sy="100000" kx="0" ky="0" algn="bl" rotWithShape="0" blurRad="203200" dist="50800" dir="5400000">
+              <a:srgbClr val="000000">
+                <a:alpha val="35000"/>
+              </a:srgbClr>
+            </a:outerShdw>
+          </a:effectLst>
+        </p:spPr>
+      </p:pic>
+      <p:sp>
+        <p:nvSpPr>
+          <p:cNvPr id="9" name="Text 6"/>
+          <p:cNvSpPr/>
+          <p:nvPr/>
+        </p:nvSpPr>
+        <p:spPr>
+          <a:xfrm>
+            <a:off x="685800" y="5440680"/>
+            <a:ext cx="5760720" cy="822960"/>
+          </a:xfrm>
+          <a:prstGeom prst="rect">
+            <a:avLst/>
+          </a:prstGeom>
+          <a:noFill/>
+          <a:ln/>
+        </p:spPr>
+        <p:txBody>
+          <a:bodyPr wrap="square" lIns="0" tIns="0" rIns="0" bIns="0" rtlCol="0" anchor="ctr"/>
+          <a:lstStyle/>
           <a:p>
             <a:pPr indent="0" marL="0">
-              <a:lnSpc>
-                <a:spcPts val="3400"/>
-              </a:lnSpc>
-              <a:buNone/>
-            </a:pPr>
-            <a:r>
-              <a:rPr lang="en-US" sz="2300" b="1" dirty="0">
-                <a:solidFill>
-                  <a:srgbClr val="FFFFFF"/>
-                </a:solidFill>
-                <a:latin typeface="Montserrat" pitchFamily="34" charset="0"/>
-                <a:ea typeface="Montserrat" pitchFamily="34" charset="-122"/>
-                <a:cs typeface="Montserrat" pitchFamily="34" charset="-120"/>
-              </a:rPr>
-              <a:t>that says don’t buy.</a:t>
-            </a:r>
-            <a:endParaRPr lang="en-US" sz="2300" dirty="0"/>
-          </a:p>
-        </p:txBody>
-      </p:sp>
-      <p:sp>
-        <p:nvSpPr>
-          <p:cNvPr id="8" name="Text 6"/>
-          <p:cNvSpPr/>
-          <p:nvPr/>
-        </p:nvSpPr>
-        <p:spPr>
-          <a:xfrm>
-            <a:off x="685800" y="5029200"/>
-            <a:ext cx="10607040" cy="640080"/>
-          </a:xfrm>
-          <a:prstGeom prst="rect">
-            <a:avLst/>
-          </a:prstGeom>
-          <a:noFill/>
-          <a:ln/>
-        </p:spPr>
-        <p:txBody>
-          <a:bodyPr wrap="square" lIns="0" tIns="0" rIns="0" bIns="0" rtlCol="0" anchor="ctr"/>
-          <a:lstStyle/>
-          <a:p>
-            <a:pPr indent="0" marL="0">
-              <a:buNone/>
-            </a:pPr>
-            <a:r>
-              <a:rPr lang="en-US" sz="2300" i="1" dirty="0">
+              <a:buNone/>
+            </a:pPr>
+            <a:r>
+              <a:rPr lang="en-US" sz="2100" i="1" dirty="0">
                 <a:solidFill>
                   <a:srgbClr val="E8B84B"/>
                 </a:solidFill>
@@ -5236,7 +5093,7 @@
               </a:rPr>
               <a:t>A company on referral fees can never say that.</a:t>
             </a:r>
-            <a:endParaRPr lang="en-US" sz="2300" dirty="0"/>
+            <a:endParaRPr lang="en-US" sz="2100" dirty="0"/>
           </a:p>
         </p:txBody>
       </p:sp>

</xml_diff>